<commit_message>
Prevent deployments against the wrong Base Sepolia token
Align the Foundry deployment allowlist and operator documentation with Circle's current Base Sepolia USDC contract, and pin a regression test that rejects the former mistyped address.

Constraint: The previous address has no bytecode at Base Sepolia block 45368845 while Circle documents 0x036CbD53842c5426634e7929541eC2318f3dCF7e.

Rejected: Deploy with the existing constant | constructor validation would reject the no-code address and the release could not proceed.

Confidence: high

Scope-risk: narrow

Reversibility: clean

Directive: Recheck official Circle addresses and onchain bytecode before future testnet deployments.

Tested: forge fmt --check; forge build --sizes; 30/30 Foundry tests including fuzz and invariants; forge lint; onchain code check against Base Sepolia.

Not-tested: Broadcast deployment awaits faucet gas.
</commit_message>
<xml_diff>
--- a/docs/submission/SplitLane-DoraHacks-Deck.pptx
+++ b/docs/submission/SplitLane-DoraHacks-Deck.pptx
@@ -2,19 +2,19 @@
 <file path=ppt/presentation.xml><?xml version="1.0" encoding="utf-8"?>
 <p:presentation xmlns:p="http://schemas.openxmlformats.org/presentationml/2006/main">
   <p:sldMasterIdLst>
-    <p:sldMasterId xmlns:r="http://schemas.openxmlformats.org/officeDocument/2006/relationships" id="2147483648" r:id="Rebf6a750d53a4516"/>
+    <p:sldMasterId xmlns:r="http://schemas.openxmlformats.org/officeDocument/2006/relationships" id="2147483648" r:id="R9f818c23a9734038"/>
   </p:sldMasterIdLst>
   <p:notesMasterIdLst>
-    <p:notesMasterId xmlns:r="http://schemas.openxmlformats.org/officeDocument/2006/relationships" r:id="R81feb82a659e44a7"/>
+    <p:notesMasterId xmlns:r="http://schemas.openxmlformats.org/officeDocument/2006/relationships" r:id="Rf2cd204ee1c44f76"/>
   </p:notesMasterIdLst>
   <p:sldIdLst>
-    <p:sldId xmlns:r="http://schemas.openxmlformats.org/officeDocument/2006/relationships" id="256" r:id="R3342388646f14ab0"/>
-    <p:sldId xmlns:r="http://schemas.openxmlformats.org/officeDocument/2006/relationships" id="257" r:id="R1ed9b7d913044594"/>
-    <p:sldId xmlns:r="http://schemas.openxmlformats.org/officeDocument/2006/relationships" id="258" r:id="Re4fd9a4fe21b4558"/>
-    <p:sldId xmlns:r="http://schemas.openxmlformats.org/officeDocument/2006/relationships" id="259" r:id="R5d9c2b39a6044d05"/>
-    <p:sldId xmlns:r="http://schemas.openxmlformats.org/officeDocument/2006/relationships" id="260" r:id="Refb5a4cea5704c70"/>
-    <p:sldId xmlns:r="http://schemas.openxmlformats.org/officeDocument/2006/relationships" id="261" r:id="R63a5d46b1c78449e"/>
-    <p:sldId xmlns:r="http://schemas.openxmlformats.org/officeDocument/2006/relationships" id="262" r:id="Rfc7c27b723a94297"/>
+    <p:sldId xmlns:r="http://schemas.openxmlformats.org/officeDocument/2006/relationships" id="256" r:id="Rdc0d65272e6e47fa"/>
+    <p:sldId xmlns:r="http://schemas.openxmlformats.org/officeDocument/2006/relationships" id="257" r:id="R75da191574e34773"/>
+    <p:sldId xmlns:r="http://schemas.openxmlformats.org/officeDocument/2006/relationships" id="258" r:id="Raf65527270ea4aa6"/>
+    <p:sldId xmlns:r="http://schemas.openxmlformats.org/officeDocument/2006/relationships" id="259" r:id="R6e1fa37bc2f7495e"/>
+    <p:sldId xmlns:r="http://schemas.openxmlformats.org/officeDocument/2006/relationships" id="260" r:id="Rb9345e11964348cb"/>
+    <p:sldId xmlns:r="http://schemas.openxmlformats.org/officeDocument/2006/relationships" id="261" r:id="Rf3c4d3d837994fe4"/>
+    <p:sldId xmlns:r="http://schemas.openxmlformats.org/officeDocument/2006/relationships" id="262" r:id="R0ff5d1134ec84e57"/>
   </p:sldIdLst>
   <p:sldSz cx="12192000" cy="6858000"/>
   <p:notesSz cx="6858000" cy="9144000"/>
@@ -948,7 +948,7 @@
           </a:p>
           <a:p xmlns:a="http://schemas.openxmlformats.org/drawingml/2006/main">
             <a:r>
-              <a:t>- Local verification record: web 13/13, Attestcoin 15/15, Foundry 29/29 (2026-08-12)</a:t>
+              <a:t>- Local verification record: web 13/13, Attestcoin 15/15, Foundry 30/30 (2026-08-12)</a:t>
             </a:r>
           </a:p>
         </p:txBody>
@@ -1016,7 +1016,7 @@
   </p:cSld>
   <p:clrMap bg1="lt1" tx1="dk1" bg2="lt2" tx2="dk2" accent1="accent1" accent2="accent2" accent3="accent3" accent4="accent4" accent5="accent5" accent6="accent6" hlink="hlink" folHlink="folHlink"/>
   <p:sldLayoutIdLst>
-    <p:sldLayoutId xmlns:r="http://schemas.openxmlformats.org/officeDocument/2006/relationships" id="2147483649" r:id="R60f37b771c7042f2"/>
+    <p:sldLayoutId xmlns:r="http://schemas.openxmlformats.org/officeDocument/2006/relationships" id="2147483649" r:id="R5eba95f1d8784f5e"/>
   </p:sldLayoutIdLst>
   <p:txStyles>
     <p:titleStyle>
@@ -1571,7 +1571,7 @@
           <p:nvPr/>
         </p:nvPicPr>
         <p:blipFill>
-          <a:blip xmlns:r="http://schemas.openxmlformats.org/officeDocument/2006/relationships" xmlns:a="http://schemas.openxmlformats.org/drawingml/2006/main" r:embed="Rd3003b6c6e8a40f3"/>
+          <a:blip xmlns:r="http://schemas.openxmlformats.org/officeDocument/2006/relationships" xmlns:a="http://schemas.openxmlformats.org/drawingml/2006/main" r:embed="R5392175efd644df8"/>
           <a:stretch xmlns:a="http://schemas.openxmlformats.org/drawingml/2006/main"/>
         </p:blipFill>
         <p:spPr>
@@ -1591,7 +1591,7 @@
           <p:cNvPr id="2" name="eyebrow">
             <a:extLst xmlns:a="http://schemas.openxmlformats.org/drawingml/2006/main">
               <a:ext uri="{FF2B5EF4-FFF2-40B4-BE49-F238E27FC236}">
-                <a16:creationId xmlns:a16="http://schemas.microsoft.com/office/drawing/2014/main" id="{32AE4682-3CC6-4F0E-897F-0E5A8888A711}"/>
+                <a16:creationId xmlns:a16="http://schemas.microsoft.com/office/drawing/2014/main" id="{A52EDC40-1261-43D2-BF98-CB38EFAE856F}"/>
               </a:ext>
             </a:extLst>
           </p:cNvPr>
@@ -1649,7 +1649,7 @@
           <p:cNvPr id="3" name="deck-title">
             <a:extLst xmlns:a="http://schemas.openxmlformats.org/drawingml/2006/main">
               <a:ext uri="{FF2B5EF4-FFF2-40B4-BE49-F238E27FC236}">
-                <a16:creationId xmlns:a16="http://schemas.microsoft.com/office/drawing/2014/main" id="{6D07BEB5-CBC3-47F8-B5F2-35E549F41528}"/>
+                <a16:creationId xmlns:a16="http://schemas.microsoft.com/office/drawing/2014/main" id="{0C808B58-E131-4C6F-92E0-08AE70630757}"/>
               </a:ext>
             </a:extLst>
           </p:cNvPr>
@@ -1707,7 +1707,7 @@
           <p:cNvPr id="4" name="deck-subtitle">
             <a:extLst xmlns:a="http://schemas.openxmlformats.org/drawingml/2006/main">
               <a:ext uri="{FF2B5EF4-FFF2-40B4-BE49-F238E27FC236}">
-                <a16:creationId xmlns:a16="http://schemas.microsoft.com/office/drawing/2014/main" id="{4A8A06B3-4E2F-4F3E-BCC9-39E60E823CC7}"/>
+                <a16:creationId xmlns:a16="http://schemas.microsoft.com/office/drawing/2014/main" id="{608C0E64-6E2A-4197-A25E-EA5F3CFB5F87}"/>
               </a:ext>
             </a:extLst>
           </p:cNvPr>
@@ -1765,7 +1765,7 @@
           <p:cNvPr id="5" name="title-rule">
             <a:extLst xmlns:a="http://schemas.openxmlformats.org/drawingml/2006/main">
               <a:ext uri="{FF2B5EF4-FFF2-40B4-BE49-F238E27FC236}">
-                <a16:creationId xmlns:a16="http://schemas.microsoft.com/office/drawing/2014/main" id="{BC9CB5FD-D8C2-4DA2-9717-94F174CAB30D}"/>
+                <a16:creationId xmlns:a16="http://schemas.microsoft.com/office/drawing/2014/main" id="{1FDC6952-DAF6-4493-8B10-84FE80B608AA}"/>
               </a:ext>
             </a:extLst>
           </p:cNvPr>
@@ -1796,7 +1796,7 @@
           <p:cNvPr id="6" name="deck-foot">
             <a:extLst xmlns:a="http://schemas.openxmlformats.org/drawingml/2006/main">
               <a:ext uri="{FF2B5EF4-FFF2-40B4-BE49-F238E27FC236}">
-                <a16:creationId xmlns:a16="http://schemas.microsoft.com/office/drawing/2014/main" id="{826771B7-8211-4D0D-94E5-37FD2F5DA935}"/>
+                <a16:creationId xmlns:a16="http://schemas.microsoft.com/office/drawing/2014/main" id="{63440178-0832-477F-9A89-5F15904CEAE3}"/>
               </a:ext>
             </a:extLst>
           </p:cNvPr>
@@ -1852,7 +1852,7 @@
     </p:spTree>
     <p:extLst>
       <p:ext uri="{BB962C8B-B14F-4D97-AF65-F5344CB8AC3E}">
-        <p14:creationId xmlns:p14="http://schemas.microsoft.com/office/powerpoint/2010/main" val="232987127"/>
+        <p14:creationId xmlns:p14="http://schemas.microsoft.com/office/powerpoint/2010/main" val="2128566086"/>
       </p:ext>
     </p:extLst>
   </p:cSld>
@@ -1883,7 +1883,7 @@
           <p:cNvPr id="7" name="slide-2-title">
             <a:extLst xmlns:a="http://schemas.openxmlformats.org/drawingml/2006/main">
               <a:ext uri="{FF2B5EF4-FFF2-40B4-BE49-F238E27FC236}">
-                <a16:creationId xmlns:a16="http://schemas.microsoft.com/office/drawing/2014/main" id="{6C89CEA3-CB51-4391-84A9-6E7F75916AF9}"/>
+                <a16:creationId xmlns:a16="http://schemas.microsoft.com/office/drawing/2014/main" id="{EFA685AE-E07C-4D75-B743-BA31515722D6}"/>
               </a:ext>
             </a:extLst>
           </p:cNvPr>
@@ -1941,7 +1941,7 @@
           <p:cNvPr id="2" name="slide-2-number">
             <a:extLst xmlns:a="http://schemas.openxmlformats.org/drawingml/2006/main">
               <a:ext uri="{FF2B5EF4-FFF2-40B4-BE49-F238E27FC236}">
-                <a16:creationId xmlns:a16="http://schemas.microsoft.com/office/drawing/2014/main" id="{64483EF1-766E-46D7-BBCC-C4C34D8D313A}"/>
+                <a16:creationId xmlns:a16="http://schemas.microsoft.com/office/drawing/2014/main" id="{988E5E71-FC28-4C00-AE09-D91DD0DA34AC}"/>
               </a:ext>
             </a:extLst>
           </p:cNvPr>
@@ -1999,7 +1999,7 @@
           <p:cNvPr id="3" name="problem-copy">
             <a:extLst xmlns:a="http://schemas.openxmlformats.org/drawingml/2006/main">
               <a:ext uri="{FF2B5EF4-FFF2-40B4-BE49-F238E27FC236}">
-                <a16:creationId xmlns:a16="http://schemas.microsoft.com/office/drawing/2014/main" id="{B0B28511-F63C-4EE7-AB7E-F0F27A460723}"/>
+                <a16:creationId xmlns:a16="http://schemas.microsoft.com/office/drawing/2014/main" id="{2BEC79A9-C234-47E6-9D2F-498760A84DEC}"/>
               </a:ext>
             </a:extLst>
           </p:cNvPr>
@@ -2131,7 +2131,7 @@
           <p:cNvPr id="4" name="screenshot-backdrop">
             <a:extLst xmlns:a="http://schemas.openxmlformats.org/drawingml/2006/main">
               <a:ext uri="{FF2B5EF4-FFF2-40B4-BE49-F238E27FC236}">
-                <a16:creationId xmlns:a16="http://schemas.microsoft.com/office/drawing/2014/main" id="{658A83A4-9EC6-4C73-BD79-4E615B38CF1E}"/>
+                <a16:creationId xmlns:a16="http://schemas.microsoft.com/office/drawing/2014/main" id="{D91D2E4D-B0D4-4DEC-943F-9E696FD0A998}"/>
               </a:ext>
             </a:extLst>
           </p:cNvPr>
@@ -2170,7 +2170,7 @@
           <p:nvPr/>
         </p:nvPicPr>
         <p:blipFill>
-          <a:blip xmlns:r="http://schemas.openxmlformats.org/officeDocument/2006/relationships" xmlns:a="http://schemas.openxmlformats.org/drawingml/2006/main" r:embed="Re2b46d657c164d6c"/>
+          <a:blip xmlns:r="http://schemas.openxmlformats.org/officeDocument/2006/relationships" xmlns:a="http://schemas.openxmlformats.org/drawingml/2006/main" r:embed="Ref0f93c5381b4912"/>
           <a:stretch xmlns:a="http://schemas.openxmlformats.org/drawingml/2006/main"/>
         </p:blipFill>
         <p:spPr>
@@ -2190,7 +2190,7 @@
           <p:cNvPr id="6" name="solution-line">
             <a:extLst xmlns:a="http://schemas.openxmlformats.org/drawingml/2006/main">
               <a:ext uri="{FF2B5EF4-FFF2-40B4-BE49-F238E27FC236}">
-                <a16:creationId xmlns:a16="http://schemas.microsoft.com/office/drawing/2014/main" id="{429154A5-2327-41E0-810F-D5C162ED6F59}"/>
+                <a16:creationId xmlns:a16="http://schemas.microsoft.com/office/drawing/2014/main" id="{E763E38C-21D0-4FDE-8C03-0CE42BD9D257}"/>
               </a:ext>
             </a:extLst>
           </p:cNvPr>
@@ -2246,7 +2246,7 @@
     </p:spTree>
     <p:extLst>
       <p:ext uri="{BB962C8B-B14F-4D97-AF65-F5344CB8AC3E}">
-        <p14:creationId xmlns:p14="http://schemas.microsoft.com/office/powerpoint/2010/main" val="1072601076"/>
+        <p14:creationId xmlns:p14="http://schemas.microsoft.com/office/powerpoint/2010/main" val="1325303022"/>
       </p:ext>
     </p:extLst>
   </p:cSld>
@@ -2277,7 +2277,7 @@
           <p:cNvPr id="16" name="slide-3-title">
             <a:extLst xmlns:a="http://schemas.openxmlformats.org/drawingml/2006/main">
               <a:ext uri="{FF2B5EF4-FFF2-40B4-BE49-F238E27FC236}">
-                <a16:creationId xmlns:a16="http://schemas.microsoft.com/office/drawing/2014/main" id="{D3C68F9A-45A6-4ABC-ADBB-FE30A5E746CE}"/>
+                <a16:creationId xmlns:a16="http://schemas.microsoft.com/office/drawing/2014/main" id="{C289D33E-07ED-4F28-B9E1-F1DB9DE863BF}"/>
               </a:ext>
             </a:extLst>
           </p:cNvPr>
@@ -2335,7 +2335,7 @@
           <p:cNvPr id="2" name="slide-3-number">
             <a:extLst xmlns:a="http://schemas.openxmlformats.org/drawingml/2006/main">
               <a:ext uri="{FF2B5EF4-FFF2-40B4-BE49-F238E27FC236}">
-                <a16:creationId xmlns:a16="http://schemas.microsoft.com/office/drawing/2014/main" id="{CD320CD5-CBDB-4EC8-B804-6197D22F4AB2}"/>
+                <a16:creationId xmlns:a16="http://schemas.microsoft.com/office/drawing/2014/main" id="{3D8F394C-138C-4F08-8B27-BF79ADE94C69}"/>
               </a:ext>
             </a:extLst>
           </p:cNvPr>
@@ -2393,7 +2393,7 @@
           <p:cNvPr id="3" name="workflow-line">
             <a:extLst xmlns:a="http://schemas.openxmlformats.org/drawingml/2006/main">
               <a:ext uri="{FF2B5EF4-FFF2-40B4-BE49-F238E27FC236}">
-                <a16:creationId xmlns:a16="http://schemas.microsoft.com/office/drawing/2014/main" id="{E9BC2E71-2D77-46CB-BEC9-9E59E3C152AC}"/>
+                <a16:creationId xmlns:a16="http://schemas.microsoft.com/office/drawing/2014/main" id="{609DDE10-8991-4BFA-9A3A-88609A4C77D9}"/>
               </a:ext>
             </a:extLst>
           </p:cNvPr>
@@ -2424,7 +2424,7 @@
           <p:cNvPr id="4" name="step-dot-0">
             <a:extLst xmlns:a="http://schemas.openxmlformats.org/drawingml/2006/main">
               <a:ext uri="{FF2B5EF4-FFF2-40B4-BE49-F238E27FC236}">
-                <a16:creationId xmlns:a16="http://schemas.microsoft.com/office/drawing/2014/main" id="{7C57B9A1-992F-463A-A35F-D813E8AE4F87}"/>
+                <a16:creationId xmlns:a16="http://schemas.microsoft.com/office/drawing/2014/main" id="{FC264734-A29F-44F8-A5B1-6A579F02D64A}"/>
               </a:ext>
             </a:extLst>
           </p:cNvPr>
@@ -2455,7 +2455,7 @@
           <p:cNvPr id="5" name="step-label-0">
             <a:extLst xmlns:a="http://schemas.openxmlformats.org/drawingml/2006/main">
               <a:ext uri="{FF2B5EF4-FFF2-40B4-BE49-F238E27FC236}">
-                <a16:creationId xmlns:a16="http://schemas.microsoft.com/office/drawing/2014/main" id="{47929FF1-7044-4E71-9191-1F9CE7DA8D73}"/>
+                <a16:creationId xmlns:a16="http://schemas.microsoft.com/office/drawing/2014/main" id="{5AC047DC-A1BB-4802-8896-8377007DA82E}"/>
               </a:ext>
             </a:extLst>
           </p:cNvPr>
@@ -2513,7 +2513,7 @@
           <p:cNvPr id="6" name="step-head-0">
             <a:extLst xmlns:a="http://schemas.openxmlformats.org/drawingml/2006/main">
               <a:ext uri="{FF2B5EF4-FFF2-40B4-BE49-F238E27FC236}">
-                <a16:creationId xmlns:a16="http://schemas.microsoft.com/office/drawing/2014/main" id="{BDFC12BD-CB7F-454B-817D-37182B34689C}"/>
+                <a16:creationId xmlns:a16="http://schemas.microsoft.com/office/drawing/2014/main" id="{1C599616-1C44-4C1B-BA2A-24D0E278BCBC}"/>
               </a:ext>
             </a:extLst>
           </p:cNvPr>
@@ -2571,7 +2571,7 @@
           <p:cNvPr id="7" name="step-body-0">
             <a:extLst xmlns:a="http://schemas.openxmlformats.org/drawingml/2006/main">
               <a:ext uri="{FF2B5EF4-FFF2-40B4-BE49-F238E27FC236}">
-                <a16:creationId xmlns:a16="http://schemas.microsoft.com/office/drawing/2014/main" id="{A8F2540F-F424-4F0C-87F5-CF3B8BF46623}"/>
+                <a16:creationId xmlns:a16="http://schemas.microsoft.com/office/drawing/2014/main" id="{E1C4BA9F-B595-484E-859C-A07E0BF823B0}"/>
               </a:ext>
             </a:extLst>
           </p:cNvPr>
@@ -2629,7 +2629,7 @@
           <p:cNvPr id="8" name="step-dot-1">
             <a:extLst xmlns:a="http://schemas.openxmlformats.org/drawingml/2006/main">
               <a:ext uri="{FF2B5EF4-FFF2-40B4-BE49-F238E27FC236}">
-                <a16:creationId xmlns:a16="http://schemas.microsoft.com/office/drawing/2014/main" id="{C5AA82E0-0938-45F4-8099-9AF3D1A367B3}"/>
+                <a16:creationId xmlns:a16="http://schemas.microsoft.com/office/drawing/2014/main" id="{88700697-317E-49CE-963C-12D4EC76C463}"/>
               </a:ext>
             </a:extLst>
           </p:cNvPr>
@@ -2660,7 +2660,7 @@
           <p:cNvPr id="9" name="step-label-1">
             <a:extLst xmlns:a="http://schemas.openxmlformats.org/drawingml/2006/main">
               <a:ext uri="{FF2B5EF4-FFF2-40B4-BE49-F238E27FC236}">
-                <a16:creationId xmlns:a16="http://schemas.microsoft.com/office/drawing/2014/main" id="{BF50437B-673B-42C1-9482-E6B0CE828ECF}"/>
+                <a16:creationId xmlns:a16="http://schemas.microsoft.com/office/drawing/2014/main" id="{24693A69-000C-456F-BC50-7DDE97FBD5E0}"/>
               </a:ext>
             </a:extLst>
           </p:cNvPr>
@@ -2718,7 +2718,7 @@
           <p:cNvPr id="10" name="step-head-1">
             <a:extLst xmlns:a="http://schemas.openxmlformats.org/drawingml/2006/main">
               <a:ext uri="{FF2B5EF4-FFF2-40B4-BE49-F238E27FC236}">
-                <a16:creationId xmlns:a16="http://schemas.microsoft.com/office/drawing/2014/main" id="{5A054420-6240-4C3D-9FBA-F307095D3C68}"/>
+                <a16:creationId xmlns:a16="http://schemas.microsoft.com/office/drawing/2014/main" id="{70ACB8CF-0DF7-4448-86D0-712B7278507A}"/>
               </a:ext>
             </a:extLst>
           </p:cNvPr>
@@ -2776,7 +2776,7 @@
           <p:cNvPr id="11" name="step-body-1">
             <a:extLst xmlns:a="http://schemas.openxmlformats.org/drawingml/2006/main">
               <a:ext uri="{FF2B5EF4-FFF2-40B4-BE49-F238E27FC236}">
-                <a16:creationId xmlns:a16="http://schemas.microsoft.com/office/drawing/2014/main" id="{20552016-7C5B-4641-8656-A65CE1E1C95A}"/>
+                <a16:creationId xmlns:a16="http://schemas.microsoft.com/office/drawing/2014/main" id="{80077175-2C5C-4E8A-884F-C445B3FB3ACD}"/>
               </a:ext>
             </a:extLst>
           </p:cNvPr>
@@ -2834,7 +2834,7 @@
           <p:cNvPr id="12" name="step-dot-2">
             <a:extLst xmlns:a="http://schemas.openxmlformats.org/drawingml/2006/main">
               <a:ext uri="{FF2B5EF4-FFF2-40B4-BE49-F238E27FC236}">
-                <a16:creationId xmlns:a16="http://schemas.microsoft.com/office/drawing/2014/main" id="{B4E1C942-1F5F-4480-81FD-4C6CBA1E3F9B}"/>
+                <a16:creationId xmlns:a16="http://schemas.microsoft.com/office/drawing/2014/main" id="{AF18B6FB-ED39-4F60-9778-6AF62CFE395A}"/>
               </a:ext>
             </a:extLst>
           </p:cNvPr>
@@ -2865,7 +2865,7 @@
           <p:cNvPr id="13" name="step-label-2">
             <a:extLst xmlns:a="http://schemas.openxmlformats.org/drawingml/2006/main">
               <a:ext uri="{FF2B5EF4-FFF2-40B4-BE49-F238E27FC236}">
-                <a16:creationId xmlns:a16="http://schemas.microsoft.com/office/drawing/2014/main" id="{986B51D5-43A5-4A9D-9919-EA953D8A65FA}"/>
+                <a16:creationId xmlns:a16="http://schemas.microsoft.com/office/drawing/2014/main" id="{C28C1369-E581-4F2B-921F-4367B918D0F1}"/>
               </a:ext>
             </a:extLst>
           </p:cNvPr>
@@ -2923,7 +2923,7 @@
           <p:cNvPr id="14" name="step-head-2">
             <a:extLst xmlns:a="http://schemas.openxmlformats.org/drawingml/2006/main">
               <a:ext uri="{FF2B5EF4-FFF2-40B4-BE49-F238E27FC236}">
-                <a16:creationId xmlns:a16="http://schemas.microsoft.com/office/drawing/2014/main" id="{ED8C7B82-4A0A-4A69-89B8-D12E7994D162}"/>
+                <a16:creationId xmlns:a16="http://schemas.microsoft.com/office/drawing/2014/main" id="{70A77DF1-789B-4D0C-8C8A-C16F130EEF19}"/>
               </a:ext>
             </a:extLst>
           </p:cNvPr>
@@ -2981,7 +2981,7 @@
           <p:cNvPr id="15" name="step-body-2">
             <a:extLst xmlns:a="http://schemas.openxmlformats.org/drawingml/2006/main">
               <a:ext uri="{FF2B5EF4-FFF2-40B4-BE49-F238E27FC236}">
-                <a16:creationId xmlns:a16="http://schemas.microsoft.com/office/drawing/2014/main" id="{1047884E-06CA-45CC-AAB2-4E75639B9853}"/>
+                <a16:creationId xmlns:a16="http://schemas.microsoft.com/office/drawing/2014/main" id="{4D36C295-CD53-41E7-B3F3-7D692CE6EB47}"/>
               </a:ext>
             </a:extLst>
           </p:cNvPr>
@@ -3037,7 +3037,7 @@
     </p:spTree>
     <p:extLst>
       <p:ext uri="{BB962C8B-B14F-4D97-AF65-F5344CB8AC3E}">
-        <p14:creationId xmlns:p14="http://schemas.microsoft.com/office/powerpoint/2010/main" val="2058509712"/>
+        <p14:creationId xmlns:p14="http://schemas.microsoft.com/office/powerpoint/2010/main" val="681956912"/>
       </p:ext>
     </p:extLst>
   </p:cSld>
@@ -3068,7 +3068,7 @@
           <p:cNvPr id="15" name="slide-4-title">
             <a:extLst xmlns:a="http://schemas.openxmlformats.org/drawingml/2006/main">
               <a:ext uri="{FF2B5EF4-FFF2-40B4-BE49-F238E27FC236}">
-                <a16:creationId xmlns:a16="http://schemas.microsoft.com/office/drawing/2014/main" id="{81ED15D4-F629-4BE7-B3E4-47AD502600ED}"/>
+                <a16:creationId xmlns:a16="http://schemas.microsoft.com/office/drawing/2014/main" id="{42220AF2-0144-4809-B7D6-11FCE7AA8D2F}"/>
               </a:ext>
             </a:extLst>
           </p:cNvPr>
@@ -3126,7 +3126,7 @@
           <p:cNvPr id="2" name="slide-4-number">
             <a:extLst xmlns:a="http://schemas.openxmlformats.org/drawingml/2006/main">
               <a:ext uri="{FF2B5EF4-FFF2-40B4-BE49-F238E27FC236}">
-                <a16:creationId xmlns:a16="http://schemas.microsoft.com/office/drawing/2014/main" id="{949E04F6-1030-4C9C-99AF-24C6B245C765}"/>
+                <a16:creationId xmlns:a16="http://schemas.microsoft.com/office/drawing/2014/main" id="{CAE8AB62-61A4-497D-80A9-2F8CAE0A3308}"/>
               </a:ext>
             </a:extLst>
           </p:cNvPr>
@@ -3184,7 +3184,7 @@
           <p:cNvPr id="3" name="architecture-region-0">
             <a:extLst xmlns:a="http://schemas.openxmlformats.org/drawingml/2006/main">
               <a:ext uri="{FF2B5EF4-FFF2-40B4-BE49-F238E27FC236}">
-                <a16:creationId xmlns:a16="http://schemas.microsoft.com/office/drawing/2014/main" id="{4D44E838-BC37-4802-8EB0-4B08544238F4}"/>
+                <a16:creationId xmlns:a16="http://schemas.microsoft.com/office/drawing/2014/main" id="{D26CE7C5-6363-4A18-B255-6F8E70C05EFE}"/>
               </a:ext>
             </a:extLst>
           </p:cNvPr>
@@ -3219,7 +3219,7 @@
           <p:cNvPr id="4" name="architecture-head-0">
             <a:extLst xmlns:a="http://schemas.openxmlformats.org/drawingml/2006/main">
               <a:ext uri="{FF2B5EF4-FFF2-40B4-BE49-F238E27FC236}">
-                <a16:creationId xmlns:a16="http://schemas.microsoft.com/office/drawing/2014/main" id="{4CB8C34B-C172-41CF-8F94-0BE7C0513982}"/>
+                <a16:creationId xmlns:a16="http://schemas.microsoft.com/office/drawing/2014/main" id="{85CCE109-297E-4D6A-9929-4306452E18C0}"/>
               </a:ext>
             </a:extLst>
           </p:cNvPr>
@@ -3277,7 +3277,7 @@
           <p:cNvPr id="5" name="architecture-body-0">
             <a:extLst xmlns:a="http://schemas.openxmlformats.org/drawingml/2006/main">
               <a:ext uri="{FF2B5EF4-FFF2-40B4-BE49-F238E27FC236}">
-                <a16:creationId xmlns:a16="http://schemas.microsoft.com/office/drawing/2014/main" id="{D40CA0D6-FA62-4078-8595-11F8C089156C}"/>
+                <a16:creationId xmlns:a16="http://schemas.microsoft.com/office/drawing/2014/main" id="{DB68D278-28ED-444F-8A7E-1D383CD7EA0B}"/>
               </a:ext>
             </a:extLst>
           </p:cNvPr>
@@ -3381,7 +3381,7 @@
           <p:cNvPr id="6" name="architecture-region-1">
             <a:extLst xmlns:a="http://schemas.openxmlformats.org/drawingml/2006/main">
               <a:ext uri="{FF2B5EF4-FFF2-40B4-BE49-F238E27FC236}">
-                <a16:creationId xmlns:a16="http://schemas.microsoft.com/office/drawing/2014/main" id="{20608D56-27A7-45A2-BB5C-7DA885D5CA30}"/>
+                <a16:creationId xmlns:a16="http://schemas.microsoft.com/office/drawing/2014/main" id="{3ECC9D3B-94B1-42D8-870C-3823682C7AF8}"/>
               </a:ext>
             </a:extLst>
           </p:cNvPr>
@@ -3416,7 +3416,7 @@
           <p:cNvPr id="7" name="architecture-head-1">
             <a:extLst xmlns:a="http://schemas.openxmlformats.org/drawingml/2006/main">
               <a:ext uri="{FF2B5EF4-FFF2-40B4-BE49-F238E27FC236}">
-                <a16:creationId xmlns:a16="http://schemas.microsoft.com/office/drawing/2014/main" id="{966EA821-B5DC-49EE-B13C-CE99B54CDAF3}"/>
+                <a16:creationId xmlns:a16="http://schemas.microsoft.com/office/drawing/2014/main" id="{AD17F223-7D90-4897-ABDC-CFCB75EC9D16}"/>
               </a:ext>
             </a:extLst>
           </p:cNvPr>
@@ -3474,7 +3474,7 @@
           <p:cNvPr id="8" name="architecture-body-1">
             <a:extLst xmlns:a="http://schemas.openxmlformats.org/drawingml/2006/main">
               <a:ext uri="{FF2B5EF4-FFF2-40B4-BE49-F238E27FC236}">
-                <a16:creationId xmlns:a16="http://schemas.microsoft.com/office/drawing/2014/main" id="{2197E314-29EA-42C8-B681-255659AE957E}"/>
+                <a16:creationId xmlns:a16="http://schemas.microsoft.com/office/drawing/2014/main" id="{8477314F-8876-44D0-91DC-516B265E3720}"/>
               </a:ext>
             </a:extLst>
           </p:cNvPr>
@@ -3578,7 +3578,7 @@
           <p:cNvPr id="9" name="architecture-region-2">
             <a:extLst xmlns:a="http://schemas.openxmlformats.org/drawingml/2006/main">
               <a:ext uri="{FF2B5EF4-FFF2-40B4-BE49-F238E27FC236}">
-                <a16:creationId xmlns:a16="http://schemas.microsoft.com/office/drawing/2014/main" id="{67D7BB23-092E-4931-8C9A-93F30CC81C7F}"/>
+                <a16:creationId xmlns:a16="http://schemas.microsoft.com/office/drawing/2014/main" id="{DC1B274C-DE3E-4F01-A84B-651E8758228E}"/>
               </a:ext>
             </a:extLst>
           </p:cNvPr>
@@ -3613,7 +3613,7 @@
           <p:cNvPr id="10" name="architecture-head-2">
             <a:extLst xmlns:a="http://schemas.openxmlformats.org/drawingml/2006/main">
               <a:ext uri="{FF2B5EF4-FFF2-40B4-BE49-F238E27FC236}">
-                <a16:creationId xmlns:a16="http://schemas.microsoft.com/office/drawing/2014/main" id="{06293B1C-6E44-4E36-924D-17ED2F9F4C38}"/>
+                <a16:creationId xmlns:a16="http://schemas.microsoft.com/office/drawing/2014/main" id="{5CF627E0-2220-4D7C-AEA7-701D520762BC}"/>
               </a:ext>
             </a:extLst>
           </p:cNvPr>
@@ -3671,7 +3671,7 @@
           <p:cNvPr id="11" name="architecture-body-2">
             <a:extLst xmlns:a="http://schemas.openxmlformats.org/drawingml/2006/main">
               <a:ext uri="{FF2B5EF4-FFF2-40B4-BE49-F238E27FC236}">
-                <a16:creationId xmlns:a16="http://schemas.microsoft.com/office/drawing/2014/main" id="{FB1C2552-5CB4-4536-BD92-9E1F7F425651}"/>
+                <a16:creationId xmlns:a16="http://schemas.microsoft.com/office/drawing/2014/main" id="{B22DC967-2988-4D01-957C-48249BD6D952}"/>
               </a:ext>
             </a:extLst>
           </p:cNvPr>
@@ -3775,7 +3775,7 @@
           <p:cNvPr id="12" name="architecture-region-3">
             <a:extLst xmlns:a="http://schemas.openxmlformats.org/drawingml/2006/main">
               <a:ext uri="{FF2B5EF4-FFF2-40B4-BE49-F238E27FC236}">
-                <a16:creationId xmlns:a16="http://schemas.microsoft.com/office/drawing/2014/main" id="{A11F4990-427A-41FB-BBFF-910245FA658C}"/>
+                <a16:creationId xmlns:a16="http://schemas.microsoft.com/office/drawing/2014/main" id="{4CEB275C-94AC-48B4-9257-26ABC2AD451B}"/>
               </a:ext>
             </a:extLst>
           </p:cNvPr>
@@ -3810,7 +3810,7 @@
           <p:cNvPr id="13" name="architecture-head-3">
             <a:extLst xmlns:a="http://schemas.openxmlformats.org/drawingml/2006/main">
               <a:ext uri="{FF2B5EF4-FFF2-40B4-BE49-F238E27FC236}">
-                <a16:creationId xmlns:a16="http://schemas.microsoft.com/office/drawing/2014/main" id="{FF275CC9-10C0-4750-B313-654AC3942E57}"/>
+                <a16:creationId xmlns:a16="http://schemas.microsoft.com/office/drawing/2014/main" id="{1E31D5E8-A15A-4498-A6AA-E50784ECC3BE}"/>
               </a:ext>
             </a:extLst>
           </p:cNvPr>
@@ -3868,7 +3868,7 @@
           <p:cNvPr id="14" name="architecture-body-3">
             <a:extLst xmlns:a="http://schemas.openxmlformats.org/drawingml/2006/main">
               <a:ext uri="{FF2B5EF4-FFF2-40B4-BE49-F238E27FC236}">
-                <a16:creationId xmlns:a16="http://schemas.microsoft.com/office/drawing/2014/main" id="{338B20F3-EF42-4DA9-8284-5008F79C30E5}"/>
+                <a16:creationId xmlns:a16="http://schemas.microsoft.com/office/drawing/2014/main" id="{C7EB6B51-1F03-483D-BED4-E69EA622F353}"/>
               </a:ext>
             </a:extLst>
           </p:cNvPr>
@@ -3970,7 +3970,7 @@
     </p:spTree>
     <p:extLst>
       <p:ext uri="{BB962C8B-B14F-4D97-AF65-F5344CB8AC3E}">
-        <p14:creationId xmlns:p14="http://schemas.microsoft.com/office/powerpoint/2010/main" val="1239271704"/>
+        <p14:creationId xmlns:p14="http://schemas.microsoft.com/office/powerpoint/2010/main" val="1216788829"/>
       </p:ext>
     </p:extLst>
   </p:cSld>
@@ -4001,7 +4001,7 @@
           <p:cNvPr id="21" name="slide-5-title">
             <a:extLst xmlns:a="http://schemas.openxmlformats.org/drawingml/2006/main">
               <a:ext uri="{FF2B5EF4-FFF2-40B4-BE49-F238E27FC236}">
-                <a16:creationId xmlns:a16="http://schemas.microsoft.com/office/drawing/2014/main" id="{21DEE2FF-70A6-48D0-81C6-BD51B3503441}"/>
+                <a16:creationId xmlns:a16="http://schemas.microsoft.com/office/drawing/2014/main" id="{805E8DB3-509E-4B19-B571-1B9F4D98EE6B}"/>
               </a:ext>
             </a:extLst>
           </p:cNvPr>
@@ -4059,7 +4059,7 @@
           <p:cNvPr id="2" name="slide-5-number">
             <a:extLst xmlns:a="http://schemas.openxmlformats.org/drawingml/2006/main">
               <a:ext uri="{FF2B5EF4-FFF2-40B4-BE49-F238E27FC236}">
-                <a16:creationId xmlns:a16="http://schemas.microsoft.com/office/drawing/2014/main" id="{A66746DE-68AF-43D2-99A9-E1B011710CC9}"/>
+                <a16:creationId xmlns:a16="http://schemas.microsoft.com/office/drawing/2014/main" id="{5FBE065B-8DAD-404E-9DC5-603678A0AA22}"/>
               </a:ext>
             </a:extLst>
           </p:cNvPr>
@@ -4117,7 +4117,7 @@
           <p:cNvPr id="3" name="security-thesis">
             <a:extLst xmlns:a="http://schemas.openxmlformats.org/drawingml/2006/main">
               <a:ext uri="{FF2B5EF4-FFF2-40B4-BE49-F238E27FC236}">
-                <a16:creationId xmlns:a16="http://schemas.microsoft.com/office/drawing/2014/main" id="{67DD59B8-8064-4A25-9B55-8E11B8E75D3A}"/>
+                <a16:creationId xmlns:a16="http://schemas.microsoft.com/office/drawing/2014/main" id="{CD57077B-E158-4353-9E9B-218E0EB71DE7}"/>
               </a:ext>
             </a:extLst>
           </p:cNvPr>
@@ -4175,7 +4175,7 @@
           <p:cNvPr id="4" name="security-copy">
             <a:extLst xmlns:a="http://schemas.openxmlformats.org/drawingml/2006/main">
               <a:ext uri="{FF2B5EF4-FFF2-40B4-BE49-F238E27FC236}">
-                <a16:creationId xmlns:a16="http://schemas.microsoft.com/office/drawing/2014/main" id="{28794C02-0A10-4511-8604-E72FEB754410}"/>
+                <a16:creationId xmlns:a16="http://schemas.microsoft.com/office/drawing/2014/main" id="{F1F5C7B5-EC89-4CBB-8F92-7DAB2F75D886}"/>
               </a:ext>
             </a:extLst>
           </p:cNvPr>
@@ -4233,7 +4233,7 @@
           <p:cNvPr id="5" name="check-0">
             <a:extLst xmlns:a="http://schemas.openxmlformats.org/drawingml/2006/main">
               <a:ext uri="{FF2B5EF4-FFF2-40B4-BE49-F238E27FC236}">
-                <a16:creationId xmlns:a16="http://schemas.microsoft.com/office/drawing/2014/main" id="{CA7BBF6E-6D7E-46B3-B9DC-7DB97A1D7D27}"/>
+                <a16:creationId xmlns:a16="http://schemas.microsoft.com/office/drawing/2014/main" id="{F6158A68-AF29-4446-9951-AC4F2D105011}"/>
               </a:ext>
             </a:extLst>
           </p:cNvPr>
@@ -4266,7 +4266,7 @@
           <p:cNvPr id="6" name="check-mark-0">
             <a:extLst xmlns:a="http://schemas.openxmlformats.org/drawingml/2006/main">
               <a:ext uri="{FF2B5EF4-FFF2-40B4-BE49-F238E27FC236}">
-                <a16:creationId xmlns:a16="http://schemas.microsoft.com/office/drawing/2014/main" id="{034ABCC9-C7D4-406D-A36F-16BEF34DFB3E}"/>
+                <a16:creationId xmlns:a16="http://schemas.microsoft.com/office/drawing/2014/main" id="{07DDFEFA-431E-4061-AD6D-B748D9DCBB8A}"/>
               </a:ext>
             </a:extLst>
           </p:cNvPr>
@@ -4324,7 +4324,7 @@
           <p:cNvPr id="7" name="check-label-0">
             <a:extLst xmlns:a="http://schemas.openxmlformats.org/drawingml/2006/main">
               <a:ext uri="{FF2B5EF4-FFF2-40B4-BE49-F238E27FC236}">
-                <a16:creationId xmlns:a16="http://schemas.microsoft.com/office/drawing/2014/main" id="{F5D12B37-59A4-4DA2-8E81-37681133B86B}"/>
+                <a16:creationId xmlns:a16="http://schemas.microsoft.com/office/drawing/2014/main" id="{99736BF7-A9F7-4D7A-966B-CFAEBA4CAA3B}"/>
               </a:ext>
             </a:extLst>
           </p:cNvPr>
@@ -4382,7 +4382,7 @@
           <p:cNvPr id="8" name="check-1">
             <a:extLst xmlns:a="http://schemas.openxmlformats.org/drawingml/2006/main">
               <a:ext uri="{FF2B5EF4-FFF2-40B4-BE49-F238E27FC236}">
-                <a16:creationId xmlns:a16="http://schemas.microsoft.com/office/drawing/2014/main" id="{93855A00-241F-4347-A2EC-58B24A451789}"/>
+                <a16:creationId xmlns:a16="http://schemas.microsoft.com/office/drawing/2014/main" id="{E22F2C2E-E229-4B7E-A930-CB2BF9F59D6A}"/>
               </a:ext>
             </a:extLst>
           </p:cNvPr>
@@ -4415,7 +4415,7 @@
           <p:cNvPr id="9" name="check-mark-1">
             <a:extLst xmlns:a="http://schemas.openxmlformats.org/drawingml/2006/main">
               <a:ext uri="{FF2B5EF4-FFF2-40B4-BE49-F238E27FC236}">
-                <a16:creationId xmlns:a16="http://schemas.microsoft.com/office/drawing/2014/main" id="{5443F484-3A35-495C-87E0-A99B1968F19B}"/>
+                <a16:creationId xmlns:a16="http://schemas.microsoft.com/office/drawing/2014/main" id="{C78B1367-4EFE-4CBC-8D24-208E38778034}"/>
               </a:ext>
             </a:extLst>
           </p:cNvPr>
@@ -4473,7 +4473,7 @@
           <p:cNvPr id="10" name="check-label-1">
             <a:extLst xmlns:a="http://schemas.openxmlformats.org/drawingml/2006/main">
               <a:ext uri="{FF2B5EF4-FFF2-40B4-BE49-F238E27FC236}">
-                <a16:creationId xmlns:a16="http://schemas.microsoft.com/office/drawing/2014/main" id="{7A255737-077D-4F58-91A1-FBA3F8E1AF67}"/>
+                <a16:creationId xmlns:a16="http://schemas.microsoft.com/office/drawing/2014/main" id="{DD5EBB09-B6B1-4D8B-93CF-5964D24492AB}"/>
               </a:ext>
             </a:extLst>
           </p:cNvPr>
@@ -4531,7 +4531,7 @@
           <p:cNvPr id="11" name="check-2">
             <a:extLst xmlns:a="http://schemas.openxmlformats.org/drawingml/2006/main">
               <a:ext uri="{FF2B5EF4-FFF2-40B4-BE49-F238E27FC236}">
-                <a16:creationId xmlns:a16="http://schemas.microsoft.com/office/drawing/2014/main" id="{4CA860E5-C787-4C14-B635-AA2A55B1CAA6}"/>
+                <a16:creationId xmlns:a16="http://schemas.microsoft.com/office/drawing/2014/main" id="{FF193FA8-07B0-456F-AE6F-4B5A88B01584}"/>
               </a:ext>
             </a:extLst>
           </p:cNvPr>
@@ -4564,7 +4564,7 @@
           <p:cNvPr id="12" name="check-mark-2">
             <a:extLst xmlns:a="http://schemas.openxmlformats.org/drawingml/2006/main">
               <a:ext uri="{FF2B5EF4-FFF2-40B4-BE49-F238E27FC236}">
-                <a16:creationId xmlns:a16="http://schemas.microsoft.com/office/drawing/2014/main" id="{18B0922A-58A1-4BF0-95A7-0683CF0545C9}"/>
+                <a16:creationId xmlns:a16="http://schemas.microsoft.com/office/drawing/2014/main" id="{E07B4A69-31A3-4075-8245-430628440570}"/>
               </a:ext>
             </a:extLst>
           </p:cNvPr>
@@ -4622,7 +4622,7 @@
           <p:cNvPr id="13" name="check-label-2">
             <a:extLst xmlns:a="http://schemas.openxmlformats.org/drawingml/2006/main">
               <a:ext uri="{FF2B5EF4-FFF2-40B4-BE49-F238E27FC236}">
-                <a16:creationId xmlns:a16="http://schemas.microsoft.com/office/drawing/2014/main" id="{43B5D16F-30CC-4B36-8F89-FC8C6C9D5D9C}"/>
+                <a16:creationId xmlns:a16="http://schemas.microsoft.com/office/drawing/2014/main" id="{B4A2B364-9668-4526-A402-AC43DB7371B0}"/>
               </a:ext>
             </a:extLst>
           </p:cNvPr>
@@ -4680,7 +4680,7 @@
           <p:cNvPr id="14" name="check-3">
             <a:extLst xmlns:a="http://schemas.openxmlformats.org/drawingml/2006/main">
               <a:ext uri="{FF2B5EF4-FFF2-40B4-BE49-F238E27FC236}">
-                <a16:creationId xmlns:a16="http://schemas.microsoft.com/office/drawing/2014/main" id="{96B4D442-5E0F-44A6-AB3D-414AB2EDB575}"/>
+                <a16:creationId xmlns:a16="http://schemas.microsoft.com/office/drawing/2014/main" id="{00515A11-675C-4ABE-9D57-1DC7A9789AA3}"/>
               </a:ext>
             </a:extLst>
           </p:cNvPr>
@@ -4713,7 +4713,7 @@
           <p:cNvPr id="15" name="check-mark-3">
             <a:extLst xmlns:a="http://schemas.openxmlformats.org/drawingml/2006/main">
               <a:ext uri="{FF2B5EF4-FFF2-40B4-BE49-F238E27FC236}">
-                <a16:creationId xmlns:a16="http://schemas.microsoft.com/office/drawing/2014/main" id="{87A4A994-67AC-4A1A-B56D-AC15734E77F3}"/>
+                <a16:creationId xmlns:a16="http://schemas.microsoft.com/office/drawing/2014/main" id="{4F22057D-B472-4F73-84A4-BCD8D86B2964}"/>
               </a:ext>
             </a:extLst>
           </p:cNvPr>
@@ -4771,7 +4771,7 @@
           <p:cNvPr id="16" name="check-label-3">
             <a:extLst xmlns:a="http://schemas.openxmlformats.org/drawingml/2006/main">
               <a:ext uri="{FF2B5EF4-FFF2-40B4-BE49-F238E27FC236}">
-                <a16:creationId xmlns:a16="http://schemas.microsoft.com/office/drawing/2014/main" id="{9050A645-17E7-4DA5-B307-276BF7C259CE}"/>
+                <a16:creationId xmlns:a16="http://schemas.microsoft.com/office/drawing/2014/main" id="{05B4E736-2664-4EB4-994D-7DD1F7FFED94}"/>
               </a:ext>
             </a:extLst>
           </p:cNvPr>
@@ -4829,7 +4829,7 @@
           <p:cNvPr id="17" name="check-4">
             <a:extLst xmlns:a="http://schemas.openxmlformats.org/drawingml/2006/main">
               <a:ext uri="{FF2B5EF4-FFF2-40B4-BE49-F238E27FC236}">
-                <a16:creationId xmlns:a16="http://schemas.microsoft.com/office/drawing/2014/main" id="{3A63C389-E547-42D8-8064-0F8BCC3E0BC9}"/>
+                <a16:creationId xmlns:a16="http://schemas.microsoft.com/office/drawing/2014/main" id="{60C1906C-E2B4-4C97-8290-4814B3CED0B2}"/>
               </a:ext>
             </a:extLst>
           </p:cNvPr>
@@ -4862,7 +4862,7 @@
           <p:cNvPr id="18" name="check-mark-4">
             <a:extLst xmlns:a="http://schemas.openxmlformats.org/drawingml/2006/main">
               <a:ext uri="{FF2B5EF4-FFF2-40B4-BE49-F238E27FC236}">
-                <a16:creationId xmlns:a16="http://schemas.microsoft.com/office/drawing/2014/main" id="{055F4FA5-B6F0-45B4-A28B-435800ACA87F}"/>
+                <a16:creationId xmlns:a16="http://schemas.microsoft.com/office/drawing/2014/main" id="{0DF69A59-ED6D-4139-A41E-25C8D5FA9980}"/>
               </a:ext>
             </a:extLst>
           </p:cNvPr>
@@ -4920,7 +4920,7 @@
           <p:cNvPr id="19" name="check-label-4">
             <a:extLst xmlns:a="http://schemas.openxmlformats.org/drawingml/2006/main">
               <a:ext uri="{FF2B5EF4-FFF2-40B4-BE49-F238E27FC236}">
-                <a16:creationId xmlns:a16="http://schemas.microsoft.com/office/drawing/2014/main" id="{8DCE21F7-35DD-4327-88DA-8FE5E8A820DB}"/>
+                <a16:creationId xmlns:a16="http://schemas.microsoft.com/office/drawing/2014/main" id="{946E23DD-8158-436B-8909-945E24E9BA71}"/>
               </a:ext>
             </a:extLst>
           </p:cNvPr>
@@ -4978,7 +4978,7 @@
           <p:cNvPr id="20" name="security-foot">
             <a:extLst xmlns:a="http://schemas.openxmlformats.org/drawingml/2006/main">
               <a:ext uri="{FF2B5EF4-FFF2-40B4-BE49-F238E27FC236}">
-                <a16:creationId xmlns:a16="http://schemas.microsoft.com/office/drawing/2014/main" id="{F41F5B07-6D20-4331-8647-0E5FA35B89ED}"/>
+                <a16:creationId xmlns:a16="http://schemas.microsoft.com/office/drawing/2014/main" id="{F96C8EE1-9E32-4B62-9908-A33FFA68303D}"/>
               </a:ext>
             </a:extLst>
           </p:cNvPr>
@@ -5034,7 +5034,7 @@
     </p:spTree>
     <p:extLst>
       <p:ext uri="{BB962C8B-B14F-4D97-AF65-F5344CB8AC3E}">
-        <p14:creationId xmlns:p14="http://schemas.microsoft.com/office/powerpoint/2010/main" val="640980010"/>
+        <p14:creationId xmlns:p14="http://schemas.microsoft.com/office/powerpoint/2010/main" val="989050549"/>
       </p:ext>
     </p:extLst>
   </p:cSld>
@@ -5065,7 +5065,7 @@
           <p:cNvPr id="11" name="slide-6-title">
             <a:extLst xmlns:a="http://schemas.openxmlformats.org/drawingml/2006/main">
               <a:ext uri="{FF2B5EF4-FFF2-40B4-BE49-F238E27FC236}">
-                <a16:creationId xmlns:a16="http://schemas.microsoft.com/office/drawing/2014/main" id="{2D5A3023-30B5-4CE3-B272-7AF4E6C713BC}"/>
+                <a16:creationId xmlns:a16="http://schemas.microsoft.com/office/drawing/2014/main" id="{D995BFF6-694F-421E-B227-97DC8F9FFE4C}"/>
               </a:ext>
             </a:extLst>
           </p:cNvPr>
@@ -5123,7 +5123,7 @@
           <p:cNvPr id="2" name="slide-6-number">
             <a:extLst xmlns:a="http://schemas.openxmlformats.org/drawingml/2006/main">
               <a:ext uri="{FF2B5EF4-FFF2-40B4-BE49-F238E27FC236}">
-                <a16:creationId xmlns:a16="http://schemas.microsoft.com/office/drawing/2014/main" id="{FF09D5D4-1C00-4A42-9E7E-6E546C91BCC4}"/>
+                <a16:creationId xmlns:a16="http://schemas.microsoft.com/office/drawing/2014/main" id="{55487DF4-55FC-4E58-8EE0-4FF74D9EF43E}"/>
               </a:ext>
             </a:extLst>
           </p:cNvPr>
@@ -5181,7 +5181,7 @@
           <p:cNvPr id="3" name="attestcoin-intro">
             <a:extLst xmlns:a="http://schemas.openxmlformats.org/drawingml/2006/main">
               <a:ext uri="{FF2B5EF4-FFF2-40B4-BE49-F238E27FC236}">
-                <a16:creationId xmlns:a16="http://schemas.microsoft.com/office/drawing/2014/main" id="{FD37FDF0-97D7-40A9-9767-3DE4A4C01955}"/>
+                <a16:creationId xmlns:a16="http://schemas.microsoft.com/office/drawing/2014/main" id="{84701C87-DE07-4032-B625-31206498FF27}"/>
               </a:ext>
             </a:extLst>
           </p:cNvPr>
@@ -5239,7 +5239,7 @@
           <p:cNvPr id="4" name="ethereum-block">
             <a:extLst xmlns:a="http://schemas.openxmlformats.org/drawingml/2006/main">
               <a:ext uri="{FF2B5EF4-FFF2-40B4-BE49-F238E27FC236}">
-                <a16:creationId xmlns:a16="http://schemas.microsoft.com/office/drawing/2014/main" id="{663D876F-6E47-4738-A65A-DE1BACA00506}"/>
+                <a16:creationId xmlns:a16="http://schemas.microsoft.com/office/drawing/2014/main" id="{DC4D4E5C-CABF-4A07-B5F2-58F46973AAB1}"/>
               </a:ext>
             </a:extLst>
           </p:cNvPr>
@@ -5274,7 +5274,7 @@
           <p:cNvPr id="5" name="base-block">
             <a:extLst xmlns:a="http://schemas.openxmlformats.org/drawingml/2006/main">
               <a:ext uri="{FF2B5EF4-FFF2-40B4-BE49-F238E27FC236}">
-                <a16:creationId xmlns:a16="http://schemas.microsoft.com/office/drawing/2014/main" id="{94712194-BC78-40BA-8A1B-B7F2313EC0FD}"/>
+                <a16:creationId xmlns:a16="http://schemas.microsoft.com/office/drawing/2014/main" id="{7053A97F-ED1B-4DAC-BB6B-FA06C712F3FE}"/>
               </a:ext>
             </a:extLst>
           </p:cNvPr>
@@ -5309,7 +5309,7 @@
           <p:cNvPr id="6" name="ethereum-head">
             <a:extLst xmlns:a="http://schemas.openxmlformats.org/drawingml/2006/main">
               <a:ext uri="{FF2B5EF4-FFF2-40B4-BE49-F238E27FC236}">
-                <a16:creationId xmlns:a16="http://schemas.microsoft.com/office/drawing/2014/main" id="{1BDC0F22-40E9-4108-B660-F6761E3CD0F4}"/>
+                <a16:creationId xmlns:a16="http://schemas.microsoft.com/office/drawing/2014/main" id="{8EB95A19-31C7-408A-A153-BD9824BED3C5}"/>
               </a:ext>
             </a:extLst>
           </p:cNvPr>
@@ -5367,7 +5367,7 @@
           <p:cNvPr id="7" name="ethereum-copy">
             <a:extLst xmlns:a="http://schemas.openxmlformats.org/drawingml/2006/main">
               <a:ext uri="{FF2B5EF4-FFF2-40B4-BE49-F238E27FC236}">
-                <a16:creationId xmlns:a16="http://schemas.microsoft.com/office/drawing/2014/main" id="{699C202C-AFD2-4B4B-9D1E-EFBC5896DF8D}"/>
+                <a16:creationId xmlns:a16="http://schemas.microsoft.com/office/drawing/2014/main" id="{F9E34E2D-144D-4983-897C-80044F76683C}"/>
               </a:ext>
             </a:extLst>
           </p:cNvPr>
@@ -5494,7 +5494,7 @@
           <p:cNvPr id="8" name="base-head">
             <a:extLst xmlns:a="http://schemas.openxmlformats.org/drawingml/2006/main">
               <a:ext uri="{FF2B5EF4-FFF2-40B4-BE49-F238E27FC236}">
-                <a16:creationId xmlns:a16="http://schemas.microsoft.com/office/drawing/2014/main" id="{FC0F2820-D272-4492-A865-72F44BFADBE0}"/>
+                <a16:creationId xmlns:a16="http://schemas.microsoft.com/office/drawing/2014/main" id="{F288B50D-C76C-420D-8D9F-2CB45DBBCB27}"/>
               </a:ext>
             </a:extLst>
           </p:cNvPr>
@@ -5552,7 +5552,7 @@
           <p:cNvPr id="9" name="base-copy">
             <a:extLst xmlns:a="http://schemas.openxmlformats.org/drawingml/2006/main">
               <a:ext uri="{FF2B5EF4-FFF2-40B4-BE49-F238E27FC236}">
-                <a16:creationId xmlns:a16="http://schemas.microsoft.com/office/drawing/2014/main" id="{B3DF4907-E57E-4572-8192-E7A77E1BDC7E}"/>
+                <a16:creationId xmlns:a16="http://schemas.microsoft.com/office/drawing/2014/main" id="{AD6C9084-070A-447A-B4F4-1FC30E25138D}"/>
               </a:ext>
             </a:extLst>
           </p:cNvPr>
@@ -5656,7 +5656,7 @@
           <p:cNvPr id="10" name="attestcoin-foot">
             <a:extLst xmlns:a="http://schemas.openxmlformats.org/drawingml/2006/main">
               <a:ext uri="{FF2B5EF4-FFF2-40B4-BE49-F238E27FC236}">
-                <a16:creationId xmlns:a16="http://schemas.microsoft.com/office/drawing/2014/main" id="{16B2919F-740D-4F7F-856A-E33699B61F96}"/>
+                <a16:creationId xmlns:a16="http://schemas.microsoft.com/office/drawing/2014/main" id="{BE5CB5E0-FA3E-439F-A835-E7683ADE0716}"/>
               </a:ext>
             </a:extLst>
           </p:cNvPr>
@@ -5712,7 +5712,7 @@
     </p:spTree>
     <p:extLst>
       <p:ext uri="{BB962C8B-B14F-4D97-AF65-F5344CB8AC3E}">
-        <p14:creationId xmlns:p14="http://schemas.microsoft.com/office/powerpoint/2010/main" val="2129785633"/>
+        <p14:creationId xmlns:p14="http://schemas.microsoft.com/office/powerpoint/2010/main" val="1329014393"/>
       </p:ext>
     </p:extLst>
   </p:cSld>
@@ -5743,7 +5743,7 @@
           <p:cNvPr id="7" name="close-eyebrow">
             <a:extLst xmlns:a="http://schemas.openxmlformats.org/drawingml/2006/main">
               <a:ext uri="{FF2B5EF4-FFF2-40B4-BE49-F238E27FC236}">
-                <a16:creationId xmlns:a16="http://schemas.microsoft.com/office/drawing/2014/main" id="{5E39328B-9A04-45F4-9F49-E64375E4462C}"/>
+                <a16:creationId xmlns:a16="http://schemas.microsoft.com/office/drawing/2014/main" id="{48075C7E-70C7-4E01-B853-3B64F692C9F6}"/>
               </a:ext>
             </a:extLst>
           </p:cNvPr>
@@ -5801,7 +5801,7 @@
           <p:cNvPr id="2" name="close-title">
             <a:extLst xmlns:a="http://schemas.openxmlformats.org/drawingml/2006/main">
               <a:ext uri="{FF2B5EF4-FFF2-40B4-BE49-F238E27FC236}">
-                <a16:creationId xmlns:a16="http://schemas.microsoft.com/office/drawing/2014/main" id="{E347AE22-697B-48D3-9CA1-8754D8F74009}"/>
+                <a16:creationId xmlns:a16="http://schemas.microsoft.com/office/drawing/2014/main" id="{C9C2B86E-2D00-4D3F-9FD4-7B0C96924804}"/>
               </a:ext>
             </a:extLst>
           </p:cNvPr>
@@ -5882,7 +5882,7 @@
           <p:cNvPr id="3" name="close-body">
             <a:extLst xmlns:a="http://schemas.openxmlformats.org/drawingml/2006/main">
               <a:ext uri="{FF2B5EF4-FFF2-40B4-BE49-F238E27FC236}">
-                <a16:creationId xmlns:a16="http://schemas.microsoft.com/office/drawing/2014/main" id="{DD7F11FE-C5EE-4842-A285-2A7397559934}"/>
+                <a16:creationId xmlns:a16="http://schemas.microsoft.com/office/drawing/2014/main" id="{CEB00877-99D5-4E06-BE8B-CE7CB5B3A68B}"/>
               </a:ext>
             </a:extLst>
           </p:cNvPr>
@@ -5930,7 +5930,7 @@
                 <a:ea typeface="Arial"/>
                 <a:cs typeface="Arial"/>
               </a:rPr>
-              <a:t>13 web tests  |  15 Attestcoin tests  |  29 Foundry tests</a:t>
+              <a:t>13 web tests  |  15 Attestcoin tests  |  30 Foundry tests</a:t>
             </a:r>
           </a:p>
           <a:p xmlns:a="http://schemas.openxmlformats.org/drawingml/2006/main">
@@ -5963,7 +5963,7 @@
           <p:cNvPr id="4" name="close-accent-blue">
             <a:extLst xmlns:a="http://schemas.openxmlformats.org/drawingml/2006/main">
               <a:ext uri="{FF2B5EF4-FFF2-40B4-BE49-F238E27FC236}">
-                <a16:creationId xmlns:a16="http://schemas.microsoft.com/office/drawing/2014/main" id="{E8BEB886-B008-4F8F-84EC-C37CB703CC3A}"/>
+                <a16:creationId xmlns:a16="http://schemas.microsoft.com/office/drawing/2014/main" id="{691F3750-9550-4310-9CA5-F513630B6129}"/>
               </a:ext>
             </a:extLst>
           </p:cNvPr>
@@ -5994,7 +5994,7 @@
           <p:cNvPr id="5" name="close-accent-green">
             <a:extLst xmlns:a="http://schemas.openxmlformats.org/drawingml/2006/main">
               <a:ext uri="{FF2B5EF4-FFF2-40B4-BE49-F238E27FC236}">
-                <a16:creationId xmlns:a16="http://schemas.microsoft.com/office/drawing/2014/main" id="{6FA2962C-C5F5-4764-AC75-4DED35E70933}"/>
+                <a16:creationId xmlns:a16="http://schemas.microsoft.com/office/drawing/2014/main" id="{73D53BE4-F27C-4820-8394-21C6EEA9229E}"/>
               </a:ext>
             </a:extLst>
           </p:cNvPr>
@@ -6025,7 +6025,7 @@
           <p:cNvPr id="6" name="close-accent-amber">
             <a:extLst xmlns:a="http://schemas.openxmlformats.org/drawingml/2006/main">
               <a:ext uri="{FF2B5EF4-FFF2-40B4-BE49-F238E27FC236}">
-                <a16:creationId xmlns:a16="http://schemas.microsoft.com/office/drawing/2014/main" id="{85D358FC-352B-4945-AC45-E868BA034600}"/>
+                <a16:creationId xmlns:a16="http://schemas.microsoft.com/office/drawing/2014/main" id="{8A68D072-8743-43EF-9CF5-A644A1B694F3}"/>
               </a:ext>
             </a:extLst>
           </p:cNvPr>
@@ -6054,7 +6054,7 @@
     </p:spTree>
     <p:extLst>
       <p:ext uri="{BB962C8B-B14F-4D97-AF65-F5344CB8AC3E}">
-        <p14:creationId xmlns:p14="http://schemas.microsoft.com/office/powerpoint/2010/main" val="370296989"/>
+        <p14:creationId xmlns:p14="http://schemas.microsoft.com/office/powerpoint/2010/main" val="1686386721"/>
       </p:ext>
     </p:extLst>
   </p:cSld>

</xml_diff>